<commit_message>
Preserve monthly report PowerPoint design
</commit_message>
<xml_diff>
--- a/render_backend/static/monthly_report_template.pptx
+++ b/render_backend/static/monthly_report_template.pptx
@@ -5,7 +5,7 @@
     <p:sldMasterId id="2147483648" r:id="rId1"/>
   </p:sldMasterIdLst>
   <p:notesMasterIdLst>
-    <p:notesMasterId r:id="rId8"/>
+    <p:notesMasterId r:id="rId9"/>
   </p:notesMasterIdLst>
   <p:sldIdLst>
     <p:sldId id="461" r:id="rId2"/>
@@ -14,6 +14,7 @@
     <p:sldId id="545" r:id="rId5"/>
     <p:sldId id="565" r:id="rId6"/>
     <p:sldId id="566" r:id="rId7"/>
+    <p:sldId id="567" r:id="rId8"/>
   </p:sldIdLst>
   <p:sldSz cx="9144000" cy="6858000" type="screen4x3"/>
   <p:notesSz cx="6858000" cy="9144000"/>
@@ -232,7 +233,7 @@
           <a:p>
             <a:fld id="{37A13B07-473E-4453-B517-BF937E307F9F}" type="datetimeFigureOut">
               <a:rPr lang="es-MX" smtClean="0"/>
-              <a:t>04/05/2026</a:t>
+              <a:t>24/05/2026</a:t>
             </a:fld>
             <a:endParaRPr lang="es-MX" dirty="0"/>
           </a:p>
@@ -859,7 +860,7 @@
           <a:p>
             <a:fld id="{A4746D18-A8C8-43F3-BE77-459E2D7B1712}" type="datetimeFigureOut">
               <a:rPr lang="es-MX" smtClean="0"/>
-              <a:t>04/05/2026</a:t>
+              <a:t>24/05/2026</a:t>
             </a:fld>
             <a:endParaRPr lang="es-MX" dirty="0"/>
           </a:p>
@@ -1037,7 +1038,7 @@
           <a:p>
             <a:fld id="{A4746D18-A8C8-43F3-BE77-459E2D7B1712}" type="datetimeFigureOut">
               <a:rPr lang="es-MX" smtClean="0"/>
-              <a:t>04/05/2026</a:t>
+              <a:t>24/05/2026</a:t>
             </a:fld>
             <a:endParaRPr lang="es-MX" dirty="0"/>
           </a:p>
@@ -1225,7 +1226,7 @@
           <a:p>
             <a:fld id="{A4746D18-A8C8-43F3-BE77-459E2D7B1712}" type="datetimeFigureOut">
               <a:rPr lang="es-MX" smtClean="0"/>
-              <a:t>04/05/2026</a:t>
+              <a:t>24/05/2026</a:t>
             </a:fld>
             <a:endParaRPr lang="es-MX" dirty="0"/>
           </a:p>
@@ -1403,7 +1404,7 @@
           <a:p>
             <a:fld id="{A4746D18-A8C8-43F3-BE77-459E2D7B1712}" type="datetimeFigureOut">
               <a:rPr lang="es-MX" smtClean="0"/>
-              <a:t>04/05/2026</a:t>
+              <a:t>24/05/2026</a:t>
             </a:fld>
             <a:endParaRPr lang="es-MX" dirty="0"/>
           </a:p>
@@ -1657,7 +1658,7 @@
           <a:p>
             <a:fld id="{A4746D18-A8C8-43F3-BE77-459E2D7B1712}" type="datetimeFigureOut">
               <a:rPr lang="es-MX" smtClean="0"/>
-              <a:t>04/05/2026</a:t>
+              <a:t>24/05/2026</a:t>
             </a:fld>
             <a:endParaRPr lang="es-MX" dirty="0"/>
           </a:p>
@@ -1953,7 +1954,7 @@
           <a:p>
             <a:fld id="{A4746D18-A8C8-43F3-BE77-459E2D7B1712}" type="datetimeFigureOut">
               <a:rPr lang="es-MX" smtClean="0"/>
-              <a:t>04/05/2026</a:t>
+              <a:t>24/05/2026</a:t>
             </a:fld>
             <a:endParaRPr lang="es-MX" dirty="0"/>
           </a:p>
@@ -2383,7 +2384,7 @@
           <a:p>
             <a:fld id="{A4746D18-A8C8-43F3-BE77-459E2D7B1712}" type="datetimeFigureOut">
               <a:rPr lang="es-MX" smtClean="0"/>
-              <a:t>04/05/2026</a:t>
+              <a:t>24/05/2026</a:t>
             </a:fld>
             <a:endParaRPr lang="es-MX" dirty="0"/>
           </a:p>
@@ -2509,7 +2510,7 @@
           <a:p>
             <a:fld id="{A4746D18-A8C8-43F3-BE77-459E2D7B1712}" type="datetimeFigureOut">
               <a:rPr lang="es-MX" smtClean="0"/>
-              <a:t>04/05/2026</a:t>
+              <a:t>24/05/2026</a:t>
             </a:fld>
             <a:endParaRPr lang="es-MX" dirty="0"/>
           </a:p>
@@ -2612,7 +2613,7 @@
           <a:p>
             <a:fld id="{A4746D18-A8C8-43F3-BE77-459E2D7B1712}" type="datetimeFigureOut">
               <a:rPr lang="es-MX" smtClean="0"/>
-              <a:t>04/05/2026</a:t>
+              <a:t>24/05/2026</a:t>
             </a:fld>
             <a:endParaRPr lang="es-MX" dirty="0"/>
           </a:p>
@@ -2897,7 +2898,7 @@
           <a:p>
             <a:fld id="{A4746D18-A8C8-43F3-BE77-459E2D7B1712}" type="datetimeFigureOut">
               <a:rPr lang="es-MX" smtClean="0"/>
-              <a:t>04/05/2026</a:t>
+              <a:t>24/05/2026</a:t>
             </a:fld>
             <a:endParaRPr lang="es-MX" dirty="0"/>
           </a:p>
@@ -3158,7 +3159,7 @@
           <a:p>
             <a:fld id="{A4746D18-A8C8-43F3-BE77-459E2D7B1712}" type="datetimeFigureOut">
               <a:rPr lang="es-MX" smtClean="0"/>
-              <a:t>04/05/2026</a:t>
+              <a:t>24/05/2026</a:t>
             </a:fld>
             <a:endParaRPr lang="es-MX" dirty="0"/>
           </a:p>
@@ -3379,7 +3380,7 @@
           <a:p>
             <a:fld id="{A4746D18-A8C8-43F3-BE77-459E2D7B1712}" type="datetimeFigureOut">
               <a:rPr lang="es-MX" smtClean="0"/>
-              <a:t>04/05/2026</a:t>
+              <a:t>24/05/2026</a:t>
             </a:fld>
             <a:endParaRPr lang="es-MX" dirty="0"/>
           </a:p>
@@ -4089,39 +4090,8 @@
                 <a:latin typeface="Candara" panose="020E0502030303020204" pitchFamily="34" charset="0"/>
                 <a:cs typeface="Arial" panose="020B0604020202020204" pitchFamily="34" charset="0"/>
               </a:rPr>
-              <a:t>Resultados Unidad </a:t>
-            </a:r>
-            <a:r>
-              <a:rPr lang="es-MX" sz="6000" b="1" dirty="0" err="1">
-                <a:solidFill>
-                  <a:schemeClr val="bg1"/>
-                </a:solidFill>
-                <a:effectLst>
-                  <a:outerShdw blurRad="38100" dist="38100" dir="2700000" algn="tl">
-                    <a:srgbClr val="000000">
-                      <a:alpha val="43137"/>
-                    </a:srgbClr>
-                  </a:outerShdw>
-                </a:effectLst>
-                <a:latin typeface="Candara" panose="020E0502030303020204" pitchFamily="34" charset="0"/>
-                <a:cs typeface="Arial" panose="020B0604020202020204" pitchFamily="34" charset="0"/>
-              </a:rPr>
-              <a:t>Peovidencia</a:t>
-            </a:r>
-            <a:endParaRPr lang="es-MX" sz="6000" b="1" dirty="0">
-              <a:solidFill>
-                <a:schemeClr val="bg1"/>
-              </a:solidFill>
-              <a:effectLst>
-                <a:outerShdw blurRad="38100" dist="38100" dir="2700000" algn="tl">
-                  <a:srgbClr val="000000">
-                    <a:alpha val="43137"/>
-                  </a:srgbClr>
-                </a:outerShdw>
-              </a:effectLst>
-              <a:latin typeface="Candara" panose="020E0502030303020204" pitchFamily="34" charset="0"/>
-              <a:cs typeface="Arial" panose="020B0604020202020204" pitchFamily="34" charset="0"/>
-            </a:endParaRPr>
+              <a:t>Resultados Unidad Providencia</a:t>
+            </a:r>
           </a:p>
         </p:txBody>
       </p:sp>
@@ -4168,7 +4138,7 @@
                 <a:latin typeface="Candara" panose="020E0502030303020204" pitchFamily="34" charset="0"/>
                 <a:cs typeface="Arial" panose="020B0604020202020204" pitchFamily="34" charset="0"/>
               </a:rPr>
-              <a:t>Reporte Mensual Abril</a:t>
+              <a:t>Reporte Mensual Mayo 2026</a:t>
             </a:r>
             <a:endParaRPr lang="es-MX" sz="3600" b="1" dirty="0">
               <a:solidFill>
@@ -5383,7 +5353,7 @@
                 <a:latin typeface="Candara" panose="020E0502030303020204" pitchFamily="34" charset="0"/>
                 <a:cs typeface="Arial" panose="020B0604020202020204" pitchFamily="34" charset="0"/>
               </a:rPr>
-              <a:t>Mes de Abril</a:t>
+              <a:t>Mes de Mayo 2026</a:t>
             </a:r>
             <a:endParaRPr lang="es-MX" sz="3200" b="1" dirty="0">
               <a:solidFill>
@@ -5420,26 +5390,14 @@
       </p:sp>
       <p:pic>
         <p:nvPicPr>
-          <p:cNvPr id="7" name="Imagen 6">
-            <a:extLst>
-              <a:ext uri="{FF2B5EF4-FFF2-40B4-BE49-F238E27FC236}">
-                <a16:creationId xmlns:a16="http://schemas.microsoft.com/office/drawing/2014/main" id="{799C80B2-54E3-0943-09AE-D54458DC871A}"/>
-              </a:ext>
-            </a:extLst>
-          </p:cNvPr>
+          <p:cNvPr id="9" name="Picture 8" descr="Equipos_de_Barrenacion_table.jpg"/>
           <p:cNvPicPr>
             <a:picLocks noChangeAspect="1"/>
           </p:cNvPicPr>
           <p:nvPr/>
         </p:nvPicPr>
         <p:blipFill>
-          <a:blip r:embed="rId3">
-            <a:extLst>
-              <a:ext uri="{28A0092B-C50C-407E-A947-70E740481C1C}">
-                <a14:useLocalDpi xmlns:a14="http://schemas.microsoft.com/office/drawing/2010/main" val="0"/>
-              </a:ext>
-            </a:extLst>
-          </a:blip>
+          <a:blip r:embed="rId3"/>
           <a:stretch>
             <a:fillRect/>
           </a:stretch>
@@ -5456,26 +5414,14 @@
       </p:pic>
       <p:pic>
         <p:nvPicPr>
-          <p:cNvPr id="9" name="Imagen 8">
-            <a:extLst>
-              <a:ext uri="{FF2B5EF4-FFF2-40B4-BE49-F238E27FC236}">
-                <a16:creationId xmlns:a16="http://schemas.microsoft.com/office/drawing/2014/main" id="{CA3AEF7B-AFFE-D689-93C9-0160164F735C}"/>
-              </a:ext>
-            </a:extLst>
-          </p:cNvPr>
+          <p:cNvPr id="8" name="Picture 7" descr="Equipos_de_Barrenacion_dashboard.jpg"/>
           <p:cNvPicPr>
             <a:picLocks noChangeAspect="1"/>
           </p:cNvPicPr>
           <p:nvPr/>
         </p:nvPicPr>
         <p:blipFill>
-          <a:blip r:embed="rId4">
-            <a:extLst>
-              <a:ext uri="{28A0092B-C50C-407E-A947-70E740481C1C}">
-                <a14:useLocalDpi xmlns:a14="http://schemas.microsoft.com/office/drawing/2010/main" val="0"/>
-              </a:ext>
-            </a:extLst>
-          </a:blip>
+          <a:blip r:embed="rId4"/>
           <a:stretch>
             <a:fillRect/>
           </a:stretch>
@@ -5739,7 +5685,7 @@
                 <a:latin typeface="Candara" panose="020E0502030303020204" pitchFamily="34" charset="0"/>
                 <a:cs typeface="Arial" panose="020B0604020202020204" pitchFamily="34" charset="0"/>
               </a:rPr>
-              <a:t>Mes de Abril</a:t>
+              <a:t>Mes de Mayo 2026</a:t>
             </a:r>
             <a:endParaRPr lang="es-MX" sz="3200" b="1" dirty="0">
               <a:solidFill>
@@ -5760,26 +5706,14 @@
       </p:sp>
       <p:pic>
         <p:nvPicPr>
-          <p:cNvPr id="8" name="Imagen 7">
-            <a:extLst>
-              <a:ext uri="{FF2B5EF4-FFF2-40B4-BE49-F238E27FC236}">
-                <a16:creationId xmlns:a16="http://schemas.microsoft.com/office/drawing/2014/main" id="{921D3A33-F053-DC17-7E95-64ECF46C7F19}"/>
-              </a:ext>
-            </a:extLst>
-          </p:cNvPr>
+          <p:cNvPr id="10" name="Picture 9" descr="Equipos_de_Rezagado_table.jpg"/>
           <p:cNvPicPr>
             <a:picLocks noChangeAspect="1"/>
           </p:cNvPicPr>
           <p:nvPr/>
         </p:nvPicPr>
         <p:blipFill>
-          <a:blip r:embed="rId3">
-            <a:extLst>
-              <a:ext uri="{28A0092B-C50C-407E-A947-70E740481C1C}">
-                <a14:useLocalDpi xmlns:a14="http://schemas.microsoft.com/office/drawing/2010/main" val="0"/>
-              </a:ext>
-            </a:extLst>
-          </a:blip>
+          <a:blip r:embed="rId3"/>
           <a:stretch>
             <a:fillRect/>
           </a:stretch>
@@ -5796,26 +5730,14 @@
       </p:pic>
       <p:pic>
         <p:nvPicPr>
-          <p:cNvPr id="11" name="Imagen 10">
-            <a:extLst>
-              <a:ext uri="{FF2B5EF4-FFF2-40B4-BE49-F238E27FC236}">
-                <a16:creationId xmlns:a16="http://schemas.microsoft.com/office/drawing/2014/main" id="{136133BD-DACB-121D-5472-0B798025373B}"/>
-              </a:ext>
-            </a:extLst>
-          </p:cNvPr>
+          <p:cNvPr id="9" name="Picture 8" descr="Equipos_de_Rezagado_dashboard.jpg"/>
           <p:cNvPicPr>
             <a:picLocks noChangeAspect="1"/>
           </p:cNvPicPr>
           <p:nvPr/>
         </p:nvPicPr>
         <p:blipFill>
-          <a:blip r:embed="rId4">
-            <a:extLst>
-              <a:ext uri="{28A0092B-C50C-407E-A947-70E740481C1C}">
-                <a14:useLocalDpi xmlns:a14="http://schemas.microsoft.com/office/drawing/2010/main" val="0"/>
-              </a:ext>
-            </a:extLst>
-          </a:blip>
+          <a:blip r:embed="rId4"/>
           <a:stretch>
             <a:fillRect/>
           </a:stretch>
@@ -6055,13 +5977,7 @@
       </p:sp>
       <p:pic>
         <p:nvPicPr>
-          <p:cNvPr id="2" name="Imagen 1">
-            <a:extLst>
-              <a:ext uri="{FF2B5EF4-FFF2-40B4-BE49-F238E27FC236}">
-                <a16:creationId xmlns:a16="http://schemas.microsoft.com/office/drawing/2014/main" id="{C3E87F5A-5526-4141-AFAE-6AAB3F7633B1}"/>
-              </a:ext>
-            </a:extLst>
-          </p:cNvPr>
+          <p:cNvPr id="7" name="Picture 6" descr="vida_util_llantas.jpg"/>
           <p:cNvPicPr>
             <a:picLocks noChangeAspect="1"/>
           </p:cNvPicPr>
@@ -6308,10 +6224,10 @@
       </p:sp>
       <p:pic>
         <p:nvPicPr>
-          <p:cNvPr id="7" name="Imagen 6">
+          <p:cNvPr id="8" name="Imagen 7">
             <a:extLst>
               <a:ext uri="{FF2B5EF4-FFF2-40B4-BE49-F238E27FC236}">
-                <a16:creationId xmlns:a16="http://schemas.microsoft.com/office/drawing/2014/main" id="{A879127B-1933-BB9D-EF65-9BB20E9B1A94}"/>
+                <a16:creationId xmlns:a16="http://schemas.microsoft.com/office/drawing/2014/main" id="{B82AF6FF-EF42-2901-726D-2E760795E0C1}"/>
               </a:ext>
             </a:extLst>
           </p:cNvPr>
@@ -6321,7 +6237,7 @@
           <p:nvPr/>
         </p:nvPicPr>
         <p:blipFill>
-          <a:blip r:embed="rId2">
+          <a:blip r:embed="rId2" cstate="print">
             <a:extLst>
               <a:ext uri="{28A0092B-C50C-407E-A947-70E740481C1C}">
                 <a14:useLocalDpi xmlns:a14="http://schemas.microsoft.com/office/drawing/2010/main" val="0"/>
@@ -6334,8 +6250,8 @@
         </p:blipFill>
         <p:spPr>
           <a:xfrm>
-            <a:off x="3457575" y="714375"/>
-            <a:ext cx="2762250" cy="6143625"/>
+            <a:off x="2133600" y="879379"/>
+            <a:ext cx="4388603" cy="5708841"/>
           </a:xfrm>
           <a:prstGeom prst="rect">
             <a:avLst/>
@@ -6360,6 +6276,83 @@
       <p:transition/>
     </mc:Fallback>
   </mc:AlternateContent>
+</p:sld>
+</file>
+
+<file path=ppt/slides/slide7.xml><?xml version="1.0" encoding="utf-8"?>
+<p:sld xmlns:a="http://schemas.openxmlformats.org/drawingml/2006/main" xmlns:r="http://schemas.openxmlformats.org/officeDocument/2006/relationships" xmlns:p="http://schemas.openxmlformats.org/presentationml/2006/main">
+  <p:cSld>
+    <p:spTree>
+      <p:nvGrpSpPr>
+        <p:cNvPr id="1" name=""/>
+        <p:cNvGrpSpPr/>
+        <p:nvPr/>
+      </p:nvGrpSpPr>
+      <p:grpSpPr>
+        <a:xfrm>
+          <a:off x="0" y="0"/>
+          <a:ext cx="0" cy="0"/>
+          <a:chOff x="0" y="0"/>
+          <a:chExt cx="0" cy="0"/>
+        </a:xfrm>
+      </p:grpSpPr>
+      <p:sp>
+        <p:nvSpPr>
+          <p:cNvPr id="2" name="TextBox 1"/>
+          <p:cNvSpPr txBox="1"/>
+          <p:nvPr/>
+        </p:nvSpPr>
+        <p:spPr>
+          <a:xfrm>
+            <a:off x="0" y="0"/>
+            <a:ext cx="1" cy="1"/>
+          </a:xfrm>
+          <a:prstGeom prst="rect">
+            <a:avLst/>
+          </a:prstGeom>
+          <a:noFill/>
+        </p:spPr>
+        <p:txBody>
+          <a:bodyPr wrap="none">
+            <a:spAutoFit/>
+          </a:bodyPr>
+          <a:lstStyle/>
+          <a:p>
+            <a:r>
+              <a:t>KPI ACEITES</a:t>
+            </a:r>
+          </a:p>
+        </p:txBody>
+      </p:sp>
+      <p:pic>
+        <p:nvPicPr>
+          <p:cNvPr id="3" name="Picture 2" descr="kpi_aceites.jpg"/>
+          <p:cNvPicPr>
+            <a:picLocks noChangeAspect="1"/>
+          </p:cNvPicPr>
+          <p:nvPr/>
+        </p:nvPicPr>
+        <p:blipFill>
+          <a:blip r:embed="rId2"/>
+          <a:stretch>
+            <a:fillRect/>
+          </a:stretch>
+        </p:blipFill>
+        <p:spPr>
+          <a:xfrm>
+            <a:off x="0" y="0"/>
+            <a:ext cx="9144000" cy="6858000"/>
+          </a:xfrm>
+          <a:prstGeom prst="rect">
+            <a:avLst/>
+          </a:prstGeom>
+        </p:spPr>
+      </p:pic>
+    </p:spTree>
+  </p:cSld>
+  <p:clrMapOvr>
+    <a:masterClrMapping/>
+  </p:clrMapOvr>
 </p:sld>
 </file>
 

</xml_diff>